<commit_message>
feat(slides): address plugin test feedback
slide_kit: video() autoplay/loop, qr(), bullets(), hide(), hbars negatives, centred callouts. SKILL: template choice order, footer credit = source, subtraction on one image, arrows over images, poll scripts, time-budget arithmetic. asset_tools: text/page types, meta and missing commands, path and type checks. Bump to 0.3.0.
</commit_message>
<xml_diff>
--- a/skills/paper-discussion-slides/assets/sample-template.pptx
+++ b/skills/paper-discussion-slides/assets/sample-template.pptx
@@ -505,7 +505,7 @@
           <a:lstStyle/>
           <a:p>
             <a:r>
-              <a:t>Cover: no header or footer. Title in the talk language; original title, authors, source type and date below.</a:t>
+              <a:t>Cover: no header or footer. Title in the talk language; original title, authors, source type and date below; the presenter goes bottom right. The footer credit on later slides names the source authors.</a:t>
             </a:r>
           </a:p>
         </p:txBody>
@@ -715,7 +715,7 @@
           <a:lstStyle/>
           <a:p>
             <a:r>
-              <a:t>Blocks: accent title bar, light grey body, keywords and numbers only.</a:t>
+              <a:t>Blocks: accent title bar, light grey body with real bullets (bullets()), keywords and numbers only. The QR placeholder shows what qr() draws when no event link is known yet.</a:t>
             </a:r>
           </a:p>
         </p:txBody>
@@ -3942,7 +3942,7 @@
                 <a:latin typeface="Arial"/>
                 <a:ea typeface="Microsoft JhengHei"/>
               </a:rPr>
-              <a:t>Presented by Your Name</a:t>
+              <a:t>Presented by Presenter Name</a:t>
             </a:r>
           </a:p>
           <a:p>
@@ -3955,7 +3955,7 @@
                 <a:latin typeface="Arial"/>
                 <a:ea typeface="Microsoft JhengHei"/>
               </a:rPr>
-              <a:t>Your Institution</a:t>
+              <a:t>Presenter Institution</a:t>
             </a:r>
           </a:p>
         </p:txBody>
@@ -4265,7 +4265,7 @@
                 <a:latin typeface="Arial"/>
                 <a:ea typeface="Microsoft JhengHei"/>
               </a:rPr>
-              <a:t>Author / Institution, 2026</a:t>
+              <a:t>Source Authors / Institution, 2026</a:t>
             </a:r>
           </a:p>
         </p:txBody>
@@ -4982,7 +4982,7 @@
                 <a:latin typeface="Arial"/>
                 <a:ea typeface="Microsoft JhengHei"/>
               </a:rPr>
-              <a:t>Author / Institution, 2026</a:t>
+              <a:t>Source Authors / Institution, 2026</a:t>
             </a:r>
           </a:p>
         </p:txBody>
@@ -5674,7 +5674,7 @@
                 <a:latin typeface="Arial"/>
                 <a:ea typeface="Microsoft JhengHei"/>
               </a:rPr>
-              <a:t>Author / Institution, 2026</a:t>
+              <a:t>Source Authors / Institution, 2026</a:t>
             </a:r>
           </a:p>
         </p:txBody>
@@ -5869,7 +5869,13 @@
           </a:bodyPr>
           <a:lstStyle/>
           <a:p>
-            <a:pPr algn="l"/>
+            <a:pPr algn="l" marL="419100" indent="-419100">
+              <a:spcAft>
+                <a:spcPts val="1000"/>
+              </a:spcAft>
+              <a:buFont typeface="Arial"/>
+              <a:buChar char="•"/>
+            </a:pPr>
             <a:r>
               <a:rPr sz="3000" b="0" i="0">
                 <a:solidFill>
@@ -5878,11 +5884,17 @@
                 <a:latin typeface="Arial"/>
                 <a:ea typeface="Microsoft JhengHei"/>
               </a:rPr>
-              <a:t>• point with a number</a:t>
-            </a:r>
-          </a:p>
-          <a:p>
-            <a:pPr algn="l"/>
+              <a:t>point with a number</a:t>
+            </a:r>
+          </a:p>
+          <a:p>
+            <a:pPr algn="l" marL="419100" indent="-419100">
+              <a:spcAft>
+                <a:spcPts val="1000"/>
+              </a:spcAft>
+              <a:buFont typeface="Arial"/>
+              <a:buChar char="•"/>
+            </a:pPr>
             <a:r>
               <a:rPr sz="3000" b="0" i="0">
                 <a:solidFill>
@@ -5891,7 +5903,7 @@
                 <a:latin typeface="Arial"/>
                 <a:ea typeface="Microsoft JhengHei"/>
               </a:rPr>
-              <a:t>• second point</a:t>
+              <a:t>second point</a:t>
             </a:r>
           </a:p>
         </p:txBody>
@@ -6046,7 +6058,13 @@
           </a:bodyPr>
           <a:lstStyle/>
           <a:p>
-            <a:pPr algn="l"/>
+            <a:pPr algn="l" marL="419100" indent="-419100">
+              <a:spcAft>
+                <a:spcPts val="1000"/>
+              </a:spcAft>
+              <a:buFont typeface="Arial"/>
+              <a:buChar char="•"/>
+            </a:pPr>
             <a:r>
               <a:rPr sz="3000" b="0" i="0">
                 <a:solidFill>
@@ -6055,11 +6073,17 @@
                 <a:latin typeface="Arial"/>
                 <a:ea typeface="Microsoft JhengHei"/>
               </a:rPr>
-              <a:t>• quote their wording</a:t>
-            </a:r>
-          </a:p>
-          <a:p>
-            <a:pPr algn="l"/>
+              <a:t>quote their wording</a:t>
+            </a:r>
+          </a:p>
+          <a:p>
+            <a:pPr algn="l" marL="419100" indent="-419100">
+              <a:spcAft>
+                <a:spcPts val="1000"/>
+              </a:spcAft>
+              <a:buFont typeface="Arial"/>
+              <a:buChar char="•"/>
+            </a:pPr>
             <a:r>
               <a:rPr sz="3000" b="0" i="0">
                 <a:solidFill>
@@ -6068,7 +6092,140 @@
                 <a:latin typeface="Arial"/>
                 <a:ea typeface="Microsoft JhengHei"/>
               </a:rPr>
-              <a:t>• "in some cases"</a:t>
+              <a:t>"in some cases"</a:t>
+            </a:r>
+          </a:p>
+        </p:txBody>
+      </p:sp>
+      <p:sp>
+        <p:nvSpPr>
+          <p:cNvPr id="18" name="Rounded Rectangle 17"/>
+          <p:cNvSpPr/>
+          <p:nvPr/>
+        </p:nvSpPr>
+        <p:spPr>
+          <a:xfrm>
+            <a:off x="15430500" y="7048500"/>
+            <a:ext cx="1905000" cy="1905000"/>
+          </a:xfrm>
+          <a:prstGeom prst="roundRect">
+            <a:avLst>
+              <a:gd name="adj" fmla="val 4000"/>
+            </a:avLst>
+          </a:prstGeom>
+          <a:solidFill>
+            <a:srgbClr val="FFFFFF"/>
+          </a:solidFill>
+          <a:ln w="25400">
+            <a:solidFill>
+              <a:srgbClr val="5F5F6E"/>
+            </a:solidFill>
+          </a:ln>
+          <a:effectLst/>
+        </p:spPr>
+        <p:style>
+          <a:lnRef idx="1">
+            <a:schemeClr val="accent1"/>
+          </a:lnRef>
+          <a:fillRef idx="3">
+            <a:schemeClr val="accent1"/>
+          </a:fillRef>
+          <a:effectRef idx="2">
+            <a:schemeClr val="accent1"/>
+          </a:effectRef>
+          <a:fontRef idx="minor">
+            <a:schemeClr val="lt1"/>
+          </a:fontRef>
+        </p:style>
+        <p:txBody>
+          <a:bodyPr rtlCol="0" anchor="ctr"/>
+          <a:lstStyle/>
+          <a:p>
+            <a:pPr algn="ctr"/>
+          </a:p>
+        </p:txBody>
+      </p:sp>
+      <p:sp>
+        <p:nvSpPr>
+          <p:cNvPr id="19" name="TextBox 18"/>
+          <p:cNvSpPr txBox="1"/>
+          <p:nvPr/>
+        </p:nvSpPr>
+        <p:spPr>
+          <a:xfrm>
+            <a:off x="15430500" y="7048500"/>
+            <a:ext cx="1905000" cy="1905000"/>
+          </a:xfrm>
+          <a:prstGeom prst="rect">
+            <a:avLst/>
+          </a:prstGeom>
+          <a:noFill/>
+        </p:spPr>
+        <p:txBody>
+          <a:bodyPr wrap="square" lIns="0" rIns="0" tIns="0" bIns="0" anchor="ctr">
+            <a:spAutoFit/>
+          </a:bodyPr>
+          <a:lstStyle/>
+          <a:p>
+            <a:pPr algn="ctr"/>
+            <a:r>
+              <a:rPr sz="2400" b="0" i="0">
+                <a:solidFill>
+                  <a:srgbClr val="5F5F6E"/>
+                </a:solidFill>
+                <a:latin typeface="Arial"/>
+                <a:ea typeface="Microsoft JhengHei"/>
+              </a:rPr>
+              <a:t>QR</a:t>
+            </a:r>
+          </a:p>
+          <a:p>
+            <a:pPr algn="ctr"/>
+            <a:r>
+              <a:rPr sz="2400" b="0" i="0">
+                <a:solidFill>
+                  <a:srgbClr val="5F5F6E"/>
+                </a:solidFill>
+                <a:latin typeface="Arial"/>
+                <a:ea typeface="Microsoft JhengHei"/>
+              </a:rPr>
+              <a:t>placeholder</a:t>
+            </a:r>
+          </a:p>
+        </p:txBody>
+      </p:sp>
+      <p:sp>
+        <p:nvSpPr>
+          <p:cNvPr id="20" name="TextBox 19"/>
+          <p:cNvSpPr txBox="1"/>
+          <p:nvPr/>
+        </p:nvSpPr>
+        <p:spPr>
+          <a:xfrm>
+            <a:off x="14547596" y="9048750"/>
+            <a:ext cx="3670808" cy="391159"/>
+          </a:xfrm>
+          <a:prstGeom prst="rect">
+            <a:avLst/>
+          </a:prstGeom>
+          <a:noFill/>
+        </p:spPr>
+        <p:txBody>
+          <a:bodyPr wrap="square" lIns="0" rIns="0" tIns="0" bIns="0" anchor="t">
+            <a:spAutoFit/>
+          </a:bodyPr>
+          <a:lstStyle/>
+          <a:p>
+            <a:pPr algn="ctr"/>
+            <a:r>
+              <a:rPr sz="2200" b="0" i="0">
+                <a:solidFill>
+                  <a:srgbClr val="5F5F6E"/>
+                </a:solidFill>
+                <a:latin typeface="Arial"/>
+                <a:ea typeface="Microsoft JhengHei"/>
+              </a:rPr>
+              <a:t>Slido QR (placeholder)</a:t>
             </a:r>
           </a:p>
         </p:txBody>

</xml_diff>